<commit_message>
Fix Lecture 3 codeImage overflow: dedicated nested-lists screenshot, dynamic code-box sizing
- The "Nested Lists" slide reused lists.png (a flat ul/ol/dl screenshot)
  even though its code showed genuine nesting -- generate and use a real
  nested-list screenshot (slides/assets/lecture-03/nested-lists.png)
- deckBuilder.js's codeImage renderer capped the code box at a flat 2.6in
  regardless of line count, so an 11-14 line snippet's text silently
  overflowed the box and spilled into the screenshot below it (visible on
  "HTML Document Structure" and the new "Nested Lists" slide). Replaced
  the flat cap with sizing based on actual line count and an empirically
  measured Courier New line height, shrinking the font (down to a 10pt
  floor) for long snippets instead of letting text overflow

Co-Authored-By: Claude Sonnet 5 <noreply@anthropic.com>
</commit_message>
<xml_diff>
--- a/slides/CSC336-Lecture-03-HTML-and-HTML5-Fundamentals.pptx
+++ b/slides/CSC336-Lecture-03-HTML-and-HTML5-Fundamentals.pptx
@@ -4010,11 +4010,11 @@
         <p:spPr>
           <a:xfrm>
             <a:off x="640080" y="1965960"/>
-            <a:ext cx="10911535" cy="2304288"/>
+            <a:ext cx="10911535" cy="1977390"/>
           </a:xfrm>
           <a:prstGeom prst="roundRect">
             <a:avLst>
-              <a:gd name="adj" fmla="val 3175"/>
+              <a:gd name="adj" fmla="val 3699"/>
             </a:avLst>
           </a:prstGeom>
           <a:solidFill>
@@ -4032,7 +4032,7 @@
         <p:spPr>
           <a:xfrm>
             <a:off x="960120" y="2194560"/>
-            <a:ext cx="10271455" cy="1847088"/>
+            <a:ext cx="10271455" cy="1520190"/>
           </a:xfrm>
           <a:prstGeom prst="rect">
             <a:avLst/>
@@ -4162,12 +4162,12 @@
         </p:nvSpPr>
         <p:spPr>
           <a:xfrm>
-            <a:off x="530352" y="4434840"/>
-            <a:ext cx="11130991" cy="1892808"/>
+            <a:off x="530352" y="4107942"/>
+            <a:ext cx="11130991" cy="2219706"/>
           </a:xfrm>
           <a:prstGeom prst="roundRect">
             <a:avLst>
-              <a:gd name="adj" fmla="val 2899"/>
+              <a:gd name="adj" fmla="val 2472"/>
             </a:avLst>
           </a:prstGeom>
           <a:solidFill>
@@ -4204,8 +4204,8 @@
         </p:blipFill>
         <p:spPr>
           <a:xfrm>
-            <a:off x="2610084" y="4544568"/>
-            <a:ext cx="6971527" cy="1673352"/>
+            <a:off x="1929122" y="4217670"/>
+            <a:ext cx="8333452" cy="2000250"/>
           </a:xfrm>
           <a:prstGeom prst="rect">
             <a:avLst/>
@@ -5632,11 +5632,11 @@
         <p:spPr>
           <a:xfrm>
             <a:off x="640080" y="1965960"/>
-            <a:ext cx="10911535" cy="2304288"/>
+            <a:ext cx="10911535" cy="1977390"/>
           </a:xfrm>
           <a:prstGeom prst="roundRect">
             <a:avLst>
-              <a:gd name="adj" fmla="val 3175"/>
+              <a:gd name="adj" fmla="val 3699"/>
             </a:avLst>
           </a:prstGeom>
           <a:solidFill>
@@ -5654,7 +5654,7 @@
         <p:spPr>
           <a:xfrm>
             <a:off x="960120" y="2194560"/>
-            <a:ext cx="10271455" cy="1847088"/>
+            <a:ext cx="10271455" cy="1520190"/>
           </a:xfrm>
           <a:prstGeom prst="rect">
             <a:avLst/>
@@ -5795,12 +5795,12 @@
         </p:nvSpPr>
         <p:spPr>
           <a:xfrm>
-            <a:off x="530352" y="4434840"/>
-            <a:ext cx="11130991" cy="1892808"/>
+            <a:off x="530352" y="4107942"/>
+            <a:ext cx="11130991" cy="2219706"/>
           </a:xfrm>
           <a:prstGeom prst="roundRect">
             <a:avLst>
-              <a:gd name="adj" fmla="val 2899"/>
+              <a:gd name="adj" fmla="val 2472"/>
             </a:avLst>
           </a:prstGeom>
           <a:solidFill>
@@ -5837,8 +5837,8 @@
         </p:blipFill>
         <p:spPr>
           <a:xfrm>
-            <a:off x="3830562" y="4544568"/>
-            <a:ext cx="4530572" cy="1673352"/>
+            <a:off x="3388026" y="4217670"/>
+            <a:ext cx="5415643" cy="2000250"/>
           </a:xfrm>
           <a:prstGeom prst="rect">
             <a:avLst/>
@@ -6042,11 +6042,11 @@
         <p:spPr>
           <a:xfrm>
             <a:off x="640080" y="1965960"/>
-            <a:ext cx="10911535" cy="1426464"/>
+            <a:ext cx="10911535" cy="1263015"/>
           </a:xfrm>
           <a:prstGeom prst="roundRect">
             <a:avLst>
-              <a:gd name="adj" fmla="val 5128"/>
+              <a:gd name="adj" fmla="val 5792"/>
             </a:avLst>
           </a:prstGeom>
           <a:solidFill>
@@ -6064,7 +6064,7 @@
         <p:spPr>
           <a:xfrm>
             <a:off x="960120" y="2194560"/>
-            <a:ext cx="10271455" cy="969264"/>
+            <a:ext cx="10271455" cy="805815"/>
           </a:xfrm>
           <a:prstGeom prst="rect">
             <a:avLst/>
@@ -6145,12 +6145,12 @@
         </p:nvSpPr>
         <p:spPr>
           <a:xfrm>
-            <a:off x="530352" y="3557016"/>
-            <a:ext cx="11130991" cy="2770632"/>
+            <a:off x="530352" y="3393567"/>
+            <a:ext cx="11130991" cy="2934081"/>
           </a:xfrm>
           <a:prstGeom prst="roundRect">
             <a:avLst>
-              <a:gd name="adj" fmla="val 1980"/>
+              <a:gd name="adj" fmla="val 1870"/>
             </a:avLst>
           </a:prstGeom>
           <a:solidFill>
@@ -6187,8 +6187,8 @@
         </p:blipFill>
         <p:spPr>
           <a:xfrm>
-            <a:off x="4175845" y="3666744"/>
-            <a:ext cx="3840005" cy="2551176"/>
+            <a:off x="4052834" y="3503295"/>
+            <a:ext cx="4086027" cy="2714625"/>
           </a:xfrm>
           <a:prstGeom prst="rect">
             <a:avLst/>
@@ -6392,11 +6392,11 @@
         <p:spPr>
           <a:xfrm>
             <a:off x="640080" y="1965960"/>
-            <a:ext cx="10911535" cy="2304288"/>
+            <a:ext cx="10911535" cy="1977390"/>
           </a:xfrm>
           <a:prstGeom prst="roundRect">
             <a:avLst>
-              <a:gd name="adj" fmla="val 3175"/>
+              <a:gd name="adj" fmla="val 3699"/>
             </a:avLst>
           </a:prstGeom>
           <a:solidFill>
@@ -6414,7 +6414,7 @@
         <p:spPr>
           <a:xfrm>
             <a:off x="960120" y="2194560"/>
-            <a:ext cx="10271455" cy="1847088"/>
+            <a:ext cx="10271455" cy="1520190"/>
           </a:xfrm>
           <a:prstGeom prst="rect">
             <a:avLst/>
@@ -6555,12 +6555,12 @@
         </p:nvSpPr>
         <p:spPr>
           <a:xfrm>
-            <a:off x="530352" y="4434840"/>
-            <a:ext cx="11130991" cy="1892808"/>
+            <a:off x="530352" y="4107942"/>
+            <a:ext cx="11130991" cy="2219706"/>
           </a:xfrm>
           <a:prstGeom prst="roundRect">
             <a:avLst>
-              <a:gd name="adj" fmla="val 2899"/>
+              <a:gd name="adj" fmla="val 2472"/>
             </a:avLst>
           </a:prstGeom>
           <a:solidFill>
@@ -6597,8 +6597,8 @@
         </p:blipFill>
         <p:spPr>
           <a:xfrm>
-            <a:off x="3240525" y="4544568"/>
-            <a:ext cx="5710646" cy="1673352"/>
+            <a:off x="2682723" y="4217670"/>
+            <a:ext cx="6826250" cy="2000250"/>
           </a:xfrm>
           <a:prstGeom prst="rect">
             <a:avLst/>
@@ -6802,11 +6802,11 @@
         <p:spPr>
           <a:xfrm>
             <a:off x="640080" y="1965960"/>
-            <a:ext cx="10911535" cy="1426464"/>
+            <a:ext cx="10911535" cy="1263015"/>
           </a:xfrm>
           <a:prstGeom prst="roundRect">
             <a:avLst>
-              <a:gd name="adj" fmla="val 5128"/>
+              <a:gd name="adj" fmla="val 5792"/>
             </a:avLst>
           </a:prstGeom>
           <a:solidFill>
@@ -6824,7 +6824,7 @@
         <p:spPr>
           <a:xfrm>
             <a:off x="960120" y="2194560"/>
-            <a:ext cx="10271455" cy="969264"/>
+            <a:ext cx="10271455" cy="805815"/>
           </a:xfrm>
           <a:prstGeom prst="rect">
             <a:avLst/>
@@ -6905,12 +6905,12 @@
         </p:nvSpPr>
         <p:spPr>
           <a:xfrm>
-            <a:off x="530352" y="3557016"/>
-            <a:ext cx="11130991" cy="2770632"/>
+            <a:off x="530352" y="3393567"/>
+            <a:ext cx="11130991" cy="2934081"/>
           </a:xfrm>
           <a:prstGeom prst="roundRect">
             <a:avLst>
-              <a:gd name="adj" fmla="val 1980"/>
+              <a:gd name="adj" fmla="val 1870"/>
             </a:avLst>
           </a:prstGeom>
           <a:solidFill>
@@ -6947,7 +6947,7 @@
         </p:blipFill>
         <p:spPr>
           <a:xfrm>
-            <a:off x="640080" y="4274279"/>
+            <a:off x="640080" y="4192554"/>
             <a:ext cx="10911535" cy="1336106"/>
           </a:xfrm>
           <a:prstGeom prst="rect">
@@ -8760,11 +8760,11 @@
         <p:spPr>
           <a:xfrm>
             <a:off x="640080" y="1965960"/>
-            <a:ext cx="10911535" cy="2377440"/>
+            <a:ext cx="10911535" cy="2453640"/>
           </a:xfrm>
           <a:prstGeom prst="roundRect">
             <a:avLst>
-              <a:gd name="adj" fmla="val 3077"/>
+              <a:gd name="adj" fmla="val 2981"/>
             </a:avLst>
           </a:prstGeom>
           <a:solidFill>
@@ -8782,7 +8782,7 @@
         <p:spPr>
           <a:xfrm>
             <a:off x="960120" y="2194560"/>
-            <a:ext cx="10271455" cy="1920240"/>
+            <a:ext cx="10271455" cy="1996440"/>
           </a:xfrm>
           <a:prstGeom prst="rect">
             <a:avLst/>
@@ -8963,12 +8963,12 @@
         </p:nvSpPr>
         <p:spPr>
           <a:xfrm>
-            <a:off x="530352" y="4507992"/>
-            <a:ext cx="11130991" cy="1819656"/>
+            <a:off x="530352" y="4584192"/>
+            <a:ext cx="11130991" cy="1743456"/>
           </a:xfrm>
           <a:prstGeom prst="roundRect">
             <a:avLst>
-              <a:gd name="adj" fmla="val 3015"/>
+              <a:gd name="adj" fmla="val 3147"/>
             </a:avLst>
           </a:prstGeom>
           <a:solidFill>
@@ -9005,8 +9005,8 @@
         </p:blipFill>
         <p:spPr>
           <a:xfrm>
-            <a:off x="4291160" y="4617720"/>
-            <a:ext cx="3609376" cy="1600200"/>
+            <a:off x="4377097" y="4693920"/>
+            <a:ext cx="3437501" cy="1524000"/>
           </a:xfrm>
           <a:prstGeom prst="rect">
             <a:avLst/>
@@ -11647,11 +11647,11 @@
         <p:spPr>
           <a:xfrm>
             <a:off x="640080" y="1965960"/>
-            <a:ext cx="10911535" cy="1426464"/>
+            <a:ext cx="10911535" cy="1263015"/>
           </a:xfrm>
           <a:prstGeom prst="roundRect">
             <a:avLst>
-              <a:gd name="adj" fmla="val 5128"/>
+              <a:gd name="adj" fmla="val 5792"/>
             </a:avLst>
           </a:prstGeom>
           <a:solidFill>
@@ -11669,7 +11669,7 @@
         <p:spPr>
           <a:xfrm>
             <a:off x="960120" y="2194560"/>
-            <a:ext cx="10271455" cy="969264"/>
+            <a:ext cx="10271455" cy="805815"/>
           </a:xfrm>
           <a:prstGeom prst="rect">
             <a:avLst/>
@@ -11750,12 +11750,12 @@
         </p:nvSpPr>
         <p:spPr>
           <a:xfrm>
-            <a:off x="530352" y="3557016"/>
-            <a:ext cx="11130991" cy="2770632"/>
+            <a:off x="530352" y="3393567"/>
+            <a:ext cx="11130991" cy="2934081"/>
           </a:xfrm>
           <a:prstGeom prst="roundRect">
             <a:avLst>
-              <a:gd name="adj" fmla="val 1980"/>
+              <a:gd name="adj" fmla="val 1870"/>
             </a:avLst>
           </a:prstGeom>
           <a:solidFill>
@@ -11792,7 +11792,7 @@
         </p:blipFill>
         <p:spPr>
           <a:xfrm>
-            <a:off x="640080" y="3860878"/>
+            <a:off x="640080" y="3779153"/>
             <a:ext cx="10911535" cy="2162909"/>
           </a:xfrm>
           <a:prstGeom prst="rect">
@@ -12487,11 +12487,11 @@
         <p:spPr>
           <a:xfrm>
             <a:off x="640080" y="1965960"/>
-            <a:ext cx="10911535" cy="2011680"/>
+            <a:ext cx="10911535" cy="1739265"/>
           </a:xfrm>
           <a:prstGeom prst="roundRect">
             <a:avLst>
-              <a:gd name="adj" fmla="val 3636"/>
+              <a:gd name="adj" fmla="val 4206"/>
             </a:avLst>
           </a:prstGeom>
           <a:solidFill>
@@ -12509,7 +12509,7 @@
         <p:spPr>
           <a:xfrm>
             <a:off x="960120" y="2194560"/>
-            <a:ext cx="10271455" cy="1554480"/>
+            <a:ext cx="10271455" cy="1282065"/>
           </a:xfrm>
           <a:prstGeom prst="rect">
             <a:avLst/>
@@ -12630,12 +12630,12 @@
         </p:nvSpPr>
         <p:spPr>
           <a:xfrm>
-            <a:off x="530352" y="4142232"/>
-            <a:ext cx="11130991" cy="2185416"/>
+            <a:off x="530352" y="3869817"/>
+            <a:ext cx="11130991" cy="2457831"/>
           </a:xfrm>
           <a:prstGeom prst="roundRect">
             <a:avLst>
-              <a:gd name="adj" fmla="val 2510"/>
+              <a:gd name="adj" fmla="val 2232"/>
             </a:avLst>
           </a:prstGeom>
           <a:solidFill>
@@ -12672,8 +12672,8 @@
         </p:blipFill>
         <p:spPr>
           <a:xfrm>
-            <a:off x="4795589" y="4251960"/>
-            <a:ext cx="2600517" cy="1965960"/>
+            <a:off x="4615417" y="3979545"/>
+            <a:ext cx="2960860" cy="2238375"/>
           </a:xfrm>
           <a:prstGeom prst="rect">
             <a:avLst/>
@@ -12877,11 +12877,11 @@
         <p:spPr>
           <a:xfrm>
             <a:off x="640080" y="1965960"/>
-            <a:ext cx="10911535" cy="841248"/>
+            <a:ext cx="10911535" cy="786765"/>
           </a:xfrm>
           <a:prstGeom prst="roundRect">
             <a:avLst>
-              <a:gd name="adj" fmla="val 8696"/>
+              <a:gd name="adj" fmla="val 9298"/>
             </a:avLst>
           </a:prstGeom>
           <a:solidFill>
@@ -12899,7 +12899,7 @@
         <p:spPr>
           <a:xfrm>
             <a:off x="960120" y="2194560"/>
-            <a:ext cx="10271455" cy="384048"/>
+            <a:ext cx="10271455" cy="329565"/>
           </a:xfrm>
           <a:prstGeom prst="rect">
             <a:avLst/>
@@ -12940,12 +12940,12 @@
         </p:nvSpPr>
         <p:spPr>
           <a:xfrm>
-            <a:off x="530352" y="2971800"/>
-            <a:ext cx="11130991" cy="3355848"/>
+            <a:off x="530352" y="2917317"/>
+            <a:ext cx="11130991" cy="3410331"/>
           </a:xfrm>
           <a:prstGeom prst="roundRect">
             <a:avLst>
-              <a:gd name="adj" fmla="val 1635"/>
+              <a:gd name="adj" fmla="val 1609"/>
             </a:avLst>
           </a:prstGeom>
           <a:solidFill>
@@ -12982,8 +12982,8 @@
         </p:blipFill>
         <p:spPr>
           <a:xfrm>
-            <a:off x="2718195" y="3081528"/>
-            <a:ext cx="6755306" cy="3136392"/>
+            <a:off x="2682088" y="3037522"/>
+            <a:ext cx="6827520" cy="3169920"/>
           </a:xfrm>
           <a:prstGeom prst="rect">
             <a:avLst/>
@@ -13187,11 +13187,11 @@
         <p:spPr>
           <a:xfrm>
             <a:off x="640080" y="1965960"/>
-            <a:ext cx="10911535" cy="2377440"/>
+            <a:ext cx="10911535" cy="2691765"/>
           </a:xfrm>
           <a:prstGeom prst="roundRect">
             <a:avLst>
-              <a:gd name="adj" fmla="val 3077"/>
+              <a:gd name="adj" fmla="val 2718"/>
             </a:avLst>
           </a:prstGeom>
           <a:solidFill>
@@ -13209,7 +13209,7 @@
         <p:spPr>
           <a:xfrm>
             <a:off x="960120" y="2194560"/>
-            <a:ext cx="10271455" cy="1920240"/>
+            <a:ext cx="10271455" cy="2234565"/>
           </a:xfrm>
           <a:prstGeom prst="rect">
             <a:avLst/>
@@ -13399,12 +13399,12 @@
         </p:nvSpPr>
         <p:spPr>
           <a:xfrm>
-            <a:off x="530352" y="4507992"/>
-            <a:ext cx="11130991" cy="1819656"/>
+            <a:off x="530352" y="4822317"/>
+            <a:ext cx="11130991" cy="1505331"/>
           </a:xfrm>
           <a:prstGeom prst="roundRect">
             <a:avLst>
-              <a:gd name="adj" fmla="val 3015"/>
+              <a:gd name="adj" fmla="val 3645"/>
             </a:avLst>
           </a:prstGeom>
           <a:solidFill>
@@ -13441,8 +13441,8 @@
         </p:blipFill>
         <p:spPr>
           <a:xfrm>
-            <a:off x="5218031" y="4617720"/>
-            <a:ext cx="1755633" cy="1600200"/>
+            <a:off x="5390459" y="4932045"/>
+            <a:ext cx="1410777" cy="1285875"/>
           </a:xfrm>
           <a:prstGeom prst="rect">
             <a:avLst/>
@@ -13646,11 +13646,11 @@
         <p:spPr>
           <a:xfrm>
             <a:off x="640080" y="1965960"/>
-            <a:ext cx="10911535" cy="2377440"/>
+            <a:ext cx="10911535" cy="2691765"/>
           </a:xfrm>
           <a:prstGeom prst="roundRect">
             <a:avLst>
-              <a:gd name="adj" fmla="val 3077"/>
+              <a:gd name="adj" fmla="val 2718"/>
             </a:avLst>
           </a:prstGeom>
           <a:solidFill>
@@ -13668,7 +13668,7 @@
         <p:spPr>
           <a:xfrm>
             <a:off x="960120" y="2194560"/>
-            <a:ext cx="10271455" cy="1920240"/>
+            <a:ext cx="10271455" cy="2234565"/>
           </a:xfrm>
           <a:prstGeom prst="rect">
             <a:avLst/>
@@ -13869,12 +13869,12 @@
         </p:nvSpPr>
         <p:spPr>
           <a:xfrm>
-            <a:off x="530352" y="4507992"/>
-            <a:ext cx="11130991" cy="1819656"/>
+            <a:off x="530352" y="4822317"/>
+            <a:ext cx="11130991" cy="1505331"/>
           </a:xfrm>
           <a:prstGeom prst="roundRect">
             <a:avLst>
-              <a:gd name="adj" fmla="val 3015"/>
+              <a:gd name="adj" fmla="val 3645"/>
             </a:avLst>
           </a:prstGeom>
           <a:solidFill>
@@ -13911,8 +13911,8 @@
         </p:blipFill>
         <p:spPr>
           <a:xfrm>
-            <a:off x="4418651" y="4617720"/>
-            <a:ext cx="3354394" cy="1600200"/>
+            <a:off x="4748100" y="4932045"/>
+            <a:ext cx="2695495" cy="1285875"/>
           </a:xfrm>
           <a:prstGeom prst="rect">
             <a:avLst/>
@@ -14116,11 +14116,11 @@
         <p:spPr>
           <a:xfrm>
             <a:off x="640080" y="1965960"/>
-            <a:ext cx="10911535" cy="2377440"/>
+            <a:ext cx="10911535" cy="3063240"/>
           </a:xfrm>
           <a:prstGeom prst="roundRect">
             <a:avLst>
-              <a:gd name="adj" fmla="val 3077"/>
+              <a:gd name="adj" fmla="val 2388"/>
             </a:avLst>
           </a:prstGeom>
           <a:solidFill>
@@ -14138,7 +14138,7 @@
         <p:spPr>
           <a:xfrm>
             <a:off x="960120" y="2194560"/>
-            <a:ext cx="10271455" cy="1920240"/>
+            <a:ext cx="10271455" cy="2606040"/>
           </a:xfrm>
           <a:prstGeom prst="rect">
             <a:avLst/>
@@ -14157,7 +14157,7 @@
               <a:buNone/>
             </a:pPr>
             <a:r>
-              <a:rPr lang="en-US" sz="1250" dirty="0">
+              <a:rPr lang="en-US" sz="1200" dirty="0">
                 <a:solidFill>
                   <a:srgbClr val="C9D3F5"/>
                 </a:solidFill>
@@ -14167,7 +14167,7 @@
               </a:rPr>
               <a:t>&lt;ul&gt;</a:t>
             </a:r>
-            <a:endParaRPr lang="en-US" sz="1250" dirty="0"/>
+            <a:endParaRPr lang="en-US" sz="1200" dirty="0"/>
           </a:p>
           <a:p>
             <a:pPr indent="0" marL="0">
@@ -14177,7 +14177,7 @@
               <a:buNone/>
             </a:pPr>
             <a:r>
-              <a:rPr lang="en-US" sz="1250" dirty="0">
+              <a:rPr lang="en-US" sz="1200" dirty="0">
                 <a:solidFill>
                   <a:srgbClr val="C9D3F5"/>
                 </a:solidFill>
@@ -14187,7 +14187,7 @@
               </a:rPr>
               <a:t>  &lt;li&gt;HTML&lt;/li&gt;&lt;li&gt;CSS&lt;/li&gt;&lt;li&gt;JavaScript&lt;/li&gt;</a:t>
             </a:r>
-            <a:endParaRPr lang="en-US" sz="1250" dirty="0"/>
+            <a:endParaRPr lang="en-US" sz="1200" dirty="0"/>
           </a:p>
           <a:p>
             <a:pPr indent="0" marL="0">
@@ -14197,7 +14197,7 @@
               <a:buNone/>
             </a:pPr>
             <a:r>
-              <a:rPr lang="en-US" sz="1250" dirty="0">
+              <a:rPr lang="en-US" sz="1200" dirty="0">
                 <a:solidFill>
                   <a:srgbClr val="C9D3F5"/>
                 </a:solidFill>
@@ -14207,7 +14207,7 @@
               </a:rPr>
               <a:t>&lt;/ul&gt;</a:t>
             </a:r>
-            <a:endParaRPr lang="en-US" sz="1250" dirty="0"/>
+            <a:endParaRPr lang="en-US" sz="1200" dirty="0"/>
           </a:p>
           <a:p>
             <a:pPr indent="0" marL="0">
@@ -14216,7 +14216,7 @@
               </a:lnSpc>
               <a:buNone/>
             </a:pPr>
-            <a:endParaRPr lang="en-US" sz="1250" dirty="0"/>
+            <a:endParaRPr lang="en-US" sz="1200" dirty="0"/>
           </a:p>
           <a:p>
             <a:pPr indent="0" marL="0">
@@ -14226,7 +14226,7 @@
               <a:buNone/>
             </a:pPr>
             <a:r>
-              <a:rPr lang="en-US" sz="1250" dirty="0">
+              <a:rPr lang="en-US" sz="1200" dirty="0">
                 <a:solidFill>
                   <a:srgbClr val="C9D3F5"/>
                 </a:solidFill>
@@ -14236,7 +14236,7 @@
               </a:rPr>
               <a:t>&lt;ol&gt;</a:t>
             </a:r>
-            <a:endParaRPr lang="en-US" sz="1250" dirty="0"/>
+            <a:endParaRPr lang="en-US" sz="1200" dirty="0"/>
           </a:p>
           <a:p>
             <a:pPr indent="0" marL="0">
@@ -14246,7 +14246,7 @@
               <a:buNone/>
             </a:pPr>
             <a:r>
-              <a:rPr lang="en-US" sz="1250" dirty="0">
+              <a:rPr lang="en-US" sz="1200" dirty="0">
                 <a:solidFill>
                   <a:srgbClr val="C9D3F5"/>
                 </a:solidFill>
@@ -14256,7 +14256,7 @@
               </a:rPr>
               <a:t>  &lt;li&gt;Write the HTML&lt;/li&gt;&lt;li&gt;Add CSS styling&lt;/li&gt;</a:t>
             </a:r>
-            <a:endParaRPr lang="en-US" sz="1250" dirty="0"/>
+            <a:endParaRPr lang="en-US" sz="1200" dirty="0"/>
           </a:p>
           <a:p>
             <a:pPr indent="0" marL="0">
@@ -14266,7 +14266,7 @@
               <a:buNone/>
             </a:pPr>
             <a:r>
-              <a:rPr lang="en-US" sz="1250" dirty="0">
+              <a:rPr lang="en-US" sz="1200" dirty="0">
                 <a:solidFill>
                   <a:srgbClr val="C9D3F5"/>
                 </a:solidFill>
@@ -14276,7 +14276,7 @@
               </a:rPr>
               <a:t>&lt;/ol&gt;</a:t>
             </a:r>
-            <a:endParaRPr lang="en-US" sz="1250" dirty="0"/>
+            <a:endParaRPr lang="en-US" sz="1200" dirty="0"/>
           </a:p>
           <a:p>
             <a:pPr indent="0" marL="0">
@@ -14285,7 +14285,7 @@
               </a:lnSpc>
               <a:buNone/>
             </a:pPr>
-            <a:endParaRPr lang="en-US" sz="1250" dirty="0"/>
+            <a:endParaRPr lang="en-US" sz="1200" dirty="0"/>
           </a:p>
           <a:p>
             <a:pPr indent="0" marL="0">
@@ -14295,7 +14295,7 @@
               <a:buNone/>
             </a:pPr>
             <a:r>
-              <a:rPr lang="en-US" sz="1250" dirty="0">
+              <a:rPr lang="en-US" sz="1200" dirty="0">
                 <a:solidFill>
                   <a:srgbClr val="C9D3F5"/>
                 </a:solidFill>
@@ -14305,7 +14305,7 @@
               </a:rPr>
               <a:t>&lt;dl&gt;</a:t>
             </a:r>
-            <a:endParaRPr lang="en-US" sz="1250" dirty="0"/>
+            <a:endParaRPr lang="en-US" sz="1200" dirty="0"/>
           </a:p>
           <a:p>
             <a:pPr indent="0" marL="0">
@@ -14315,7 +14315,7 @@
               <a:buNone/>
             </a:pPr>
             <a:r>
-              <a:rPr lang="en-US" sz="1250" dirty="0">
+              <a:rPr lang="en-US" sz="1200" dirty="0">
                 <a:solidFill>
                   <a:srgbClr val="C9D3F5"/>
                 </a:solidFill>
@@ -14325,7 +14325,7 @@
               </a:rPr>
               <a:t>  &lt;dt&gt;HTML&lt;/dt&gt;&lt;dd&gt;The markup language...&lt;/dd&gt;</a:t>
             </a:r>
-            <a:endParaRPr lang="en-US" sz="1250" dirty="0"/>
+            <a:endParaRPr lang="en-US" sz="1200" dirty="0"/>
           </a:p>
           <a:p>
             <a:pPr indent="0" marL="0">
@@ -14335,7 +14335,7 @@
               <a:buNone/>
             </a:pPr>
             <a:r>
-              <a:rPr lang="en-US" sz="1250" dirty="0">
+              <a:rPr lang="en-US" sz="1200" dirty="0">
                 <a:solidFill>
                   <a:srgbClr val="C9D3F5"/>
                 </a:solidFill>
@@ -14345,7 +14345,7 @@
               </a:rPr>
               <a:t>&lt;/dl&gt;</a:t>
             </a:r>
-            <a:endParaRPr lang="en-US" sz="1250" dirty="0"/>
+            <a:endParaRPr lang="en-US" sz="1200" dirty="0"/>
           </a:p>
         </p:txBody>
       </p:sp>
@@ -14357,12 +14357,12 @@
         </p:nvSpPr>
         <p:spPr>
           <a:xfrm>
-            <a:off x="530352" y="4507992"/>
-            <a:ext cx="11130991" cy="1819656"/>
+            <a:off x="530352" y="5193792"/>
+            <a:ext cx="11130991" cy="1133856"/>
           </a:xfrm>
           <a:prstGeom prst="roundRect">
             <a:avLst>
-              <a:gd name="adj" fmla="val 3015"/>
+              <a:gd name="adj" fmla="val 4839"/>
             </a:avLst>
           </a:prstGeom>
           <a:solidFill>
@@ -14399,8 +14399,8 @@
         </p:blipFill>
         <p:spPr>
           <a:xfrm>
-            <a:off x="4650941" y="4617720"/>
-            <a:ext cx="2889813" cy="1600200"/>
+            <a:off x="5270187" y="5303520"/>
+            <a:ext cx="1651322" cy="914400"/>
           </a:xfrm>
           <a:prstGeom prst="rect">
             <a:avLst/>
@@ -14604,11 +14604,11 @@
         <p:spPr>
           <a:xfrm>
             <a:off x="640080" y="1965960"/>
-            <a:ext cx="10911535" cy="2304288"/>
+            <a:ext cx="10911535" cy="1977390"/>
           </a:xfrm>
           <a:prstGeom prst="roundRect">
             <a:avLst>
-              <a:gd name="adj" fmla="val 3175"/>
+              <a:gd name="adj" fmla="val 3699"/>
             </a:avLst>
           </a:prstGeom>
           <a:solidFill>
@@ -14626,7 +14626,7 @@
         <p:spPr>
           <a:xfrm>
             <a:off x="960120" y="2194560"/>
-            <a:ext cx="10271455" cy="1847088"/>
+            <a:ext cx="10271455" cy="1520190"/>
           </a:xfrm>
           <a:prstGeom prst="rect">
             <a:avLst/>
@@ -14767,12 +14767,12 @@
         </p:nvSpPr>
         <p:spPr>
           <a:xfrm>
-            <a:off x="530352" y="4434840"/>
-            <a:ext cx="11130991" cy="1892808"/>
+            <a:off x="530352" y="4107942"/>
+            <a:ext cx="11130991" cy="2219706"/>
           </a:xfrm>
           <a:prstGeom prst="roundRect">
             <a:avLst>
-              <a:gd name="adj" fmla="val 2899"/>
+              <a:gd name="adj" fmla="val 2472"/>
             </a:avLst>
           </a:prstGeom>
           <a:solidFill>
@@ -14809,8 +14809,8 @@
         </p:blipFill>
         <p:spPr>
           <a:xfrm>
-            <a:off x="2148258" y="4544568"/>
-            <a:ext cx="7895179" cy="1673352"/>
+            <a:off x="1377076" y="4217670"/>
+            <a:ext cx="9437543" cy="2000250"/>
           </a:xfrm>
           <a:prstGeom prst="rect">
             <a:avLst/>
@@ -15014,11 +15014,11 @@
         <p:spPr>
           <a:xfrm>
             <a:off x="640080" y="1965960"/>
-            <a:ext cx="10911535" cy="2377440"/>
+            <a:ext cx="10911535" cy="3215640"/>
           </a:xfrm>
           <a:prstGeom prst="roundRect">
             <a:avLst>
-              <a:gd name="adj" fmla="val 3077"/>
+              <a:gd name="adj" fmla="val 2275"/>
             </a:avLst>
           </a:prstGeom>
           <a:solidFill>
@@ -15036,7 +15036,7 @@
         <p:spPr>
           <a:xfrm>
             <a:off x="960120" y="2194560"/>
-            <a:ext cx="10271455" cy="1920240"/>
+            <a:ext cx="10271455" cy="2758440"/>
           </a:xfrm>
           <a:prstGeom prst="rect">
             <a:avLst/>
@@ -15055,7 +15055,7 @@
               <a:buNone/>
             </a:pPr>
             <a:r>
-              <a:rPr lang="en-US" sz="1250" dirty="0">
+              <a:rPr lang="en-US" sz="1000" dirty="0">
                 <a:solidFill>
                   <a:srgbClr val="C9D3F5"/>
                 </a:solidFill>
@@ -15065,7 +15065,7 @@
               </a:rPr>
               <a:t>&lt;ul&gt;</a:t>
             </a:r>
-            <a:endParaRPr lang="en-US" sz="1250" dirty="0"/>
+            <a:endParaRPr lang="en-US" sz="1000" dirty="0"/>
           </a:p>
           <a:p>
             <a:pPr indent="0" marL="0">
@@ -15075,7 +15075,7 @@
               <a:buNone/>
             </a:pPr>
             <a:r>
-              <a:rPr lang="en-US" sz="1250" dirty="0">
+              <a:rPr lang="en-US" sz="1000" dirty="0">
                 <a:solidFill>
                   <a:srgbClr val="C9D3F5"/>
                 </a:solidFill>
@@ -15085,7 +15085,7 @@
               </a:rPr>
               <a:t>  &lt;li&gt;Front End</a:t>
             </a:r>
-            <a:endParaRPr lang="en-US" sz="1250" dirty="0"/>
+            <a:endParaRPr lang="en-US" sz="1000" dirty="0"/>
           </a:p>
           <a:p>
             <a:pPr indent="0" marL="0">
@@ -15095,7 +15095,7 @@
               <a:buNone/>
             </a:pPr>
             <a:r>
-              <a:rPr lang="en-US" sz="1250" dirty="0">
+              <a:rPr lang="en-US" sz="1000" dirty="0">
                 <a:solidFill>
                   <a:srgbClr val="C9D3F5"/>
                 </a:solidFill>
@@ -15105,7 +15105,7 @@
               </a:rPr>
               <a:t>    &lt;ul&gt;</a:t>
             </a:r>
-            <a:endParaRPr lang="en-US" sz="1250" dirty="0"/>
+            <a:endParaRPr lang="en-US" sz="1000" dirty="0"/>
           </a:p>
           <a:p>
             <a:pPr indent="0" marL="0">
@@ -15115,7 +15115,7 @@
               <a:buNone/>
             </a:pPr>
             <a:r>
-              <a:rPr lang="en-US" sz="1250" dirty="0">
+              <a:rPr lang="en-US" sz="1000" dirty="0">
                 <a:solidFill>
                   <a:srgbClr val="C9D3F5"/>
                 </a:solidFill>
@@ -15125,7 +15125,7 @@
               </a:rPr>
               <a:t>      &lt;li&gt;HTML&lt;/li&gt;</a:t>
             </a:r>
-            <a:endParaRPr lang="en-US" sz="1250" dirty="0"/>
+            <a:endParaRPr lang="en-US" sz="1000" dirty="0"/>
           </a:p>
           <a:p>
             <a:pPr indent="0" marL="0">
@@ -15135,7 +15135,7 @@
               <a:buNone/>
             </a:pPr>
             <a:r>
-              <a:rPr lang="en-US" sz="1250" dirty="0">
+              <a:rPr lang="en-US" sz="1000" dirty="0">
                 <a:solidFill>
                   <a:srgbClr val="C9D3F5"/>
                 </a:solidFill>
@@ -15145,7 +15145,7 @@
               </a:rPr>
               <a:t>      &lt;li&gt;CSS&lt;/li&gt;</a:t>
             </a:r>
-            <a:endParaRPr lang="en-US" sz="1250" dirty="0"/>
+            <a:endParaRPr lang="en-US" sz="1000" dirty="0"/>
           </a:p>
           <a:p>
             <a:pPr indent="0" marL="0">
@@ -15155,7 +15155,7 @@
               <a:buNone/>
             </a:pPr>
             <a:r>
-              <a:rPr lang="en-US" sz="1250" dirty="0">
+              <a:rPr lang="en-US" sz="1000" dirty="0">
                 <a:solidFill>
                   <a:srgbClr val="C9D3F5"/>
                 </a:solidFill>
@@ -15165,7 +15165,7 @@
               </a:rPr>
               <a:t>    &lt;/ul&gt;</a:t>
             </a:r>
-            <a:endParaRPr lang="en-US" sz="1250" dirty="0"/>
+            <a:endParaRPr lang="en-US" sz="1000" dirty="0"/>
           </a:p>
           <a:p>
             <a:pPr indent="0" marL="0">
@@ -15175,7 +15175,7 @@
               <a:buNone/>
             </a:pPr>
             <a:r>
-              <a:rPr lang="en-US" sz="1250" dirty="0">
+              <a:rPr lang="en-US" sz="1000" dirty="0">
                 <a:solidFill>
                   <a:srgbClr val="C9D3F5"/>
                 </a:solidFill>
@@ -15185,7 +15185,7 @@
               </a:rPr>
               <a:t>  &lt;/li&gt;</a:t>
             </a:r>
-            <a:endParaRPr lang="en-US" sz="1250" dirty="0"/>
+            <a:endParaRPr lang="en-US" sz="1000" dirty="0"/>
           </a:p>
           <a:p>
             <a:pPr indent="0" marL="0">
@@ -15195,7 +15195,7 @@
               <a:buNone/>
             </a:pPr>
             <a:r>
-              <a:rPr lang="en-US" sz="1250" dirty="0">
+              <a:rPr lang="en-US" sz="1000" dirty="0">
                 <a:solidFill>
                   <a:srgbClr val="C9D3F5"/>
                 </a:solidFill>
@@ -15205,7 +15205,7 @@
               </a:rPr>
               <a:t>  &lt;li&gt;Back End</a:t>
             </a:r>
-            <a:endParaRPr lang="en-US" sz="1250" dirty="0"/>
+            <a:endParaRPr lang="en-US" sz="1000" dirty="0"/>
           </a:p>
           <a:p>
             <a:pPr indent="0" marL="0">
@@ -15215,7 +15215,7 @@
               <a:buNone/>
             </a:pPr>
             <a:r>
-              <a:rPr lang="en-US" sz="1250" dirty="0">
+              <a:rPr lang="en-US" sz="1000" dirty="0">
                 <a:solidFill>
                   <a:srgbClr val="C9D3F5"/>
                 </a:solidFill>
@@ -15225,7 +15225,7 @@
               </a:rPr>
               <a:t>    &lt;ul&gt;</a:t>
             </a:r>
-            <a:endParaRPr lang="en-US" sz="1250" dirty="0"/>
+            <a:endParaRPr lang="en-US" sz="1000" dirty="0"/>
           </a:p>
           <a:p>
             <a:pPr indent="0" marL="0">
@@ -15235,7 +15235,7 @@
               <a:buNone/>
             </a:pPr>
             <a:r>
-              <a:rPr lang="en-US" sz="1250" dirty="0">
+              <a:rPr lang="en-US" sz="1000" dirty="0">
                 <a:solidFill>
                   <a:srgbClr val="C9D3F5"/>
                 </a:solidFill>
@@ -15245,7 +15245,7 @@
               </a:rPr>
               <a:t>      &lt;li&gt;Node.js&lt;/li&gt;</a:t>
             </a:r>
-            <a:endParaRPr lang="en-US" sz="1250" dirty="0"/>
+            <a:endParaRPr lang="en-US" sz="1000" dirty="0"/>
           </a:p>
           <a:p>
             <a:pPr indent="0" marL="0">
@@ -15255,7 +15255,7 @@
               <a:buNone/>
             </a:pPr>
             <a:r>
-              <a:rPr lang="en-US" sz="1250" dirty="0">
+              <a:rPr lang="en-US" sz="1000" dirty="0">
                 <a:solidFill>
                   <a:srgbClr val="C9D3F5"/>
                 </a:solidFill>
@@ -15265,7 +15265,7 @@
               </a:rPr>
               <a:t>      &lt;li&gt;Express&lt;/li&gt;</a:t>
             </a:r>
-            <a:endParaRPr lang="en-US" sz="1250" dirty="0"/>
+            <a:endParaRPr lang="en-US" sz="1000" dirty="0"/>
           </a:p>
           <a:p>
             <a:pPr indent="0" marL="0">
@@ -15275,7 +15275,7 @@
               <a:buNone/>
             </a:pPr>
             <a:r>
-              <a:rPr lang="en-US" sz="1250" dirty="0">
+              <a:rPr lang="en-US" sz="1000" dirty="0">
                 <a:solidFill>
                   <a:srgbClr val="C9D3F5"/>
                 </a:solidFill>
@@ -15285,7 +15285,7 @@
               </a:rPr>
               <a:t>    &lt;/ul&gt;</a:t>
             </a:r>
-            <a:endParaRPr lang="en-US" sz="1250" dirty="0"/>
+            <a:endParaRPr lang="en-US" sz="1000" dirty="0"/>
           </a:p>
           <a:p>
             <a:pPr indent="0" marL="0">
@@ -15295,7 +15295,7 @@
               <a:buNone/>
             </a:pPr>
             <a:r>
-              <a:rPr lang="en-US" sz="1250" dirty="0">
+              <a:rPr lang="en-US" sz="1000" dirty="0">
                 <a:solidFill>
                   <a:srgbClr val="C9D3F5"/>
                 </a:solidFill>
@@ -15305,7 +15305,7 @@
               </a:rPr>
               <a:t>  &lt;/li&gt;</a:t>
             </a:r>
-            <a:endParaRPr lang="en-US" sz="1250" dirty="0"/>
+            <a:endParaRPr lang="en-US" sz="1000" dirty="0"/>
           </a:p>
           <a:p>
             <a:pPr indent="0" marL="0">
@@ -15315,7 +15315,7 @@
               <a:buNone/>
             </a:pPr>
             <a:r>
-              <a:rPr lang="en-US" sz="1250" dirty="0">
+              <a:rPr lang="en-US" sz="1000" dirty="0">
                 <a:solidFill>
                   <a:srgbClr val="C9D3F5"/>
                 </a:solidFill>
@@ -15325,7 +15325,7 @@
               </a:rPr>
               <a:t>&lt;/ul&gt;</a:t>
             </a:r>
-            <a:endParaRPr lang="en-US" sz="1250" dirty="0"/>
+            <a:endParaRPr lang="en-US" sz="1000" dirty="0"/>
           </a:p>
         </p:txBody>
       </p:sp>
@@ -15337,12 +15337,12 @@
         </p:nvSpPr>
         <p:spPr>
           <a:xfrm>
-            <a:off x="530352" y="4507992"/>
-            <a:ext cx="11130991" cy="1819656"/>
+            <a:off x="530352" y="5346192"/>
+            <a:ext cx="11130991" cy="981456"/>
           </a:xfrm>
           <a:prstGeom prst="roundRect">
             <a:avLst>
-              <a:gd name="adj" fmla="val 3015"/>
+              <a:gd name="adj" fmla="val 5590"/>
             </a:avLst>
           </a:prstGeom>
           <a:solidFill>
@@ -15365,7 +15365,7 @@
       </p:sp>
       <p:pic>
         <p:nvPicPr>
-          <p:cNvPr id="7" name="Image 0" descr="D:/GitHub/mern-web-book/docs/assets/img/lecture-03/lists.png">    </p:cNvPr>
+          <p:cNvPr id="7" name="Image 0" descr="D:/GitHub/mern-web-book/slides/assets/lecture-03/nested-lists.png">    </p:cNvPr>
           <p:cNvPicPr>
             <a:picLocks noChangeAspect="1"/>
           </p:cNvPicPr>
@@ -15379,8 +15379,8 @@
         </p:blipFill>
         <p:spPr>
           <a:xfrm>
-            <a:off x="4650941" y="4617720"/>
-            <a:ext cx="2889813" cy="1600200"/>
+            <a:off x="5750210" y="5455920"/>
+            <a:ext cx="691275" cy="762000"/>
           </a:xfrm>
           <a:prstGeom prst="rect">
             <a:avLst/>
@@ -19683,11 +19683,11 @@
         <p:spPr>
           <a:xfrm>
             <a:off x="640080" y="1965960"/>
-            <a:ext cx="10911535" cy="1133856"/>
+            <a:ext cx="10911535" cy="1024890"/>
           </a:xfrm>
           <a:prstGeom prst="roundRect">
             <a:avLst>
-              <a:gd name="adj" fmla="val 6452"/>
+              <a:gd name="adj" fmla="val 7138"/>
             </a:avLst>
           </a:prstGeom>
           <a:solidFill>
@@ -19705,7 +19705,7 @@
         <p:spPr>
           <a:xfrm>
             <a:off x="960120" y="2194560"/>
-            <a:ext cx="10271455" cy="676656"/>
+            <a:ext cx="10271455" cy="567690"/>
           </a:xfrm>
           <a:prstGeom prst="rect">
             <a:avLst/>
@@ -19766,12 +19766,12 @@
         </p:nvSpPr>
         <p:spPr>
           <a:xfrm>
-            <a:off x="530352" y="3264408"/>
-            <a:ext cx="11130991" cy="3063240"/>
+            <a:off x="530352" y="3155442"/>
+            <a:ext cx="11130991" cy="3172206"/>
           </a:xfrm>
           <a:prstGeom prst="roundRect">
             <a:avLst>
-              <a:gd name="adj" fmla="val 1791"/>
+              <a:gd name="adj" fmla="val 1730"/>
             </a:avLst>
           </a:prstGeom>
           <a:solidFill>
@@ -19808,7 +19808,7 @@
         </p:blipFill>
         <p:spPr>
           <a:xfrm>
-            <a:off x="3352648" y="4064508"/>
+            <a:off x="3352648" y="4010025"/>
             <a:ext cx="5486400" cy="1463040"/>
           </a:xfrm>
           <a:prstGeom prst="rect">
@@ -20013,11 +20013,11 @@
         <p:spPr>
           <a:xfrm>
             <a:off x="640080" y="1965960"/>
-            <a:ext cx="10911535" cy="2377440"/>
+            <a:ext cx="10911535" cy="3063240"/>
           </a:xfrm>
           <a:prstGeom prst="roundRect">
             <a:avLst>
-              <a:gd name="adj" fmla="val 3077"/>
+              <a:gd name="adj" fmla="val 2388"/>
             </a:avLst>
           </a:prstGeom>
           <a:solidFill>
@@ -20035,7 +20035,7 @@
         <p:spPr>
           <a:xfrm>
             <a:off x="960120" y="2194560"/>
-            <a:ext cx="10271455" cy="1920240"/>
+            <a:ext cx="10271455" cy="2606040"/>
           </a:xfrm>
           <a:prstGeom prst="rect">
             <a:avLst/>
@@ -20054,7 +20054,7 @@
               <a:buNone/>
             </a:pPr>
             <a:r>
-              <a:rPr lang="en-US" sz="1250" dirty="0">
+              <a:rPr lang="en-US" sz="1200" dirty="0">
                 <a:solidFill>
                   <a:srgbClr val="C9D3F5"/>
                 </a:solidFill>
@@ -20064,7 +20064,7 @@
               </a:rPr>
               <a:t>&lt;!DOCTYPE html&gt;</a:t>
             </a:r>
-            <a:endParaRPr lang="en-US" sz="1250" dirty="0"/>
+            <a:endParaRPr lang="en-US" sz="1200" dirty="0"/>
           </a:p>
           <a:p>
             <a:pPr indent="0" marL="0">
@@ -20074,7 +20074,7 @@
               <a:buNone/>
             </a:pPr>
             <a:r>
-              <a:rPr lang="en-US" sz="1250" dirty="0">
+              <a:rPr lang="en-US" sz="1200" dirty="0">
                 <a:solidFill>
                   <a:srgbClr val="C9D3F5"/>
                 </a:solidFill>
@@ -20084,7 +20084,7 @@
               </a:rPr>
               <a:t>&lt;html lang="en"&gt;</a:t>
             </a:r>
-            <a:endParaRPr lang="en-US" sz="1250" dirty="0"/>
+            <a:endParaRPr lang="en-US" sz="1200" dirty="0"/>
           </a:p>
           <a:p>
             <a:pPr indent="0" marL="0">
@@ -20094,7 +20094,7 @@
               <a:buNone/>
             </a:pPr>
             <a:r>
-              <a:rPr lang="en-US" sz="1250" dirty="0">
+              <a:rPr lang="en-US" sz="1200" dirty="0">
                 <a:solidFill>
                   <a:srgbClr val="C9D3F5"/>
                 </a:solidFill>
@@ -20104,7 +20104,7 @@
               </a:rPr>
               <a:t>&lt;head&gt;</a:t>
             </a:r>
-            <a:endParaRPr lang="en-US" sz="1250" dirty="0"/>
+            <a:endParaRPr lang="en-US" sz="1200" dirty="0"/>
           </a:p>
           <a:p>
             <a:pPr indent="0" marL="0">
@@ -20114,7 +20114,7 @@
               <a:buNone/>
             </a:pPr>
             <a:r>
-              <a:rPr lang="en-US" sz="1250" dirty="0">
+              <a:rPr lang="en-US" sz="1200" dirty="0">
                 <a:solidFill>
                   <a:srgbClr val="C9D3F5"/>
                 </a:solidFill>
@@ -20124,7 +20124,7 @@
               </a:rPr>
               <a:t>    &lt;meta charset="UTF-8"&gt;</a:t>
             </a:r>
-            <a:endParaRPr lang="en-US" sz="1250" dirty="0"/>
+            <a:endParaRPr lang="en-US" sz="1200" dirty="0"/>
           </a:p>
           <a:p>
             <a:pPr indent="0" marL="0">
@@ -20134,7 +20134,7 @@
               <a:buNone/>
             </a:pPr>
             <a:r>
-              <a:rPr lang="en-US" sz="1250" dirty="0">
+              <a:rPr lang="en-US" sz="1200" dirty="0">
                 <a:solidFill>
                   <a:srgbClr val="C9D3F5"/>
                 </a:solidFill>
@@ -20144,7 +20144,7 @@
               </a:rPr>
               <a:t>    &lt;title&gt;My First Page&lt;/title&gt;</a:t>
             </a:r>
-            <a:endParaRPr lang="en-US" sz="1250" dirty="0"/>
+            <a:endParaRPr lang="en-US" sz="1200" dirty="0"/>
           </a:p>
           <a:p>
             <a:pPr indent="0" marL="0">
@@ -20154,7 +20154,7 @@
               <a:buNone/>
             </a:pPr>
             <a:r>
-              <a:rPr lang="en-US" sz="1250" dirty="0">
+              <a:rPr lang="en-US" sz="1200" dirty="0">
                 <a:solidFill>
                   <a:srgbClr val="C9D3F5"/>
                 </a:solidFill>
@@ -20164,7 +20164,7 @@
               </a:rPr>
               <a:t>&lt;/head&gt;</a:t>
             </a:r>
-            <a:endParaRPr lang="en-US" sz="1250" dirty="0"/>
+            <a:endParaRPr lang="en-US" sz="1200" dirty="0"/>
           </a:p>
           <a:p>
             <a:pPr indent="0" marL="0">
@@ -20174,7 +20174,7 @@
               <a:buNone/>
             </a:pPr>
             <a:r>
-              <a:rPr lang="en-US" sz="1250" dirty="0">
+              <a:rPr lang="en-US" sz="1200" dirty="0">
                 <a:solidFill>
                   <a:srgbClr val="C9D3F5"/>
                 </a:solidFill>
@@ -20184,7 +20184,7 @@
               </a:rPr>
               <a:t>&lt;body&gt;</a:t>
             </a:r>
-            <a:endParaRPr lang="en-US" sz="1250" dirty="0"/>
+            <a:endParaRPr lang="en-US" sz="1200" dirty="0"/>
           </a:p>
           <a:p>
             <a:pPr indent="0" marL="0">
@@ -20194,7 +20194,7 @@
               <a:buNone/>
             </a:pPr>
             <a:r>
-              <a:rPr lang="en-US" sz="1250" dirty="0">
+              <a:rPr lang="en-US" sz="1200" dirty="0">
                 <a:solidFill>
                   <a:srgbClr val="C9D3F5"/>
                 </a:solidFill>
@@ -20204,7 +20204,7 @@
               </a:rPr>
               <a:t>    &lt;h1&gt;Hello, Web!&lt;/h1&gt;</a:t>
             </a:r>
-            <a:endParaRPr lang="en-US" sz="1250" dirty="0"/>
+            <a:endParaRPr lang="en-US" sz="1200" dirty="0"/>
           </a:p>
           <a:p>
             <a:pPr indent="0" marL="0">
@@ -20214,7 +20214,7 @@
               <a:buNone/>
             </a:pPr>
             <a:r>
-              <a:rPr lang="en-US" sz="1250" dirty="0">
+              <a:rPr lang="en-US" sz="1200" dirty="0">
                 <a:solidFill>
                   <a:srgbClr val="C9D3F5"/>
                 </a:solidFill>
@@ -20224,7 +20224,7 @@
               </a:rPr>
               <a:t>    &lt;p&gt;This is my first HTML page.&lt;/p&gt;</a:t>
             </a:r>
-            <a:endParaRPr lang="en-US" sz="1250" dirty="0"/>
+            <a:endParaRPr lang="en-US" sz="1200" dirty="0"/>
           </a:p>
           <a:p>
             <a:pPr indent="0" marL="0">
@@ -20234,7 +20234,7 @@
               <a:buNone/>
             </a:pPr>
             <a:r>
-              <a:rPr lang="en-US" sz="1250" dirty="0">
+              <a:rPr lang="en-US" sz="1200" dirty="0">
                 <a:solidFill>
                   <a:srgbClr val="C9D3F5"/>
                 </a:solidFill>
@@ -20244,7 +20244,7 @@
               </a:rPr>
               <a:t>&lt;/body&gt;</a:t>
             </a:r>
-            <a:endParaRPr lang="en-US" sz="1250" dirty="0"/>
+            <a:endParaRPr lang="en-US" sz="1200" dirty="0"/>
           </a:p>
           <a:p>
             <a:pPr indent="0" marL="0">
@@ -20254,7 +20254,7 @@
               <a:buNone/>
             </a:pPr>
             <a:r>
-              <a:rPr lang="en-US" sz="1250" dirty="0">
+              <a:rPr lang="en-US" sz="1200" dirty="0">
                 <a:solidFill>
                   <a:srgbClr val="C9D3F5"/>
                 </a:solidFill>
@@ -20264,7 +20264,7 @@
               </a:rPr>
               <a:t>&lt;/html&gt;</a:t>
             </a:r>
-            <a:endParaRPr lang="en-US" sz="1250" dirty="0"/>
+            <a:endParaRPr lang="en-US" sz="1200" dirty="0"/>
           </a:p>
         </p:txBody>
       </p:sp>
@@ -20276,12 +20276,12 @@
         </p:nvSpPr>
         <p:spPr>
           <a:xfrm>
-            <a:off x="530352" y="4507992"/>
-            <a:ext cx="11130991" cy="1819656"/>
+            <a:off x="530352" y="5193792"/>
+            <a:ext cx="11130991" cy="1133856"/>
           </a:xfrm>
           <a:prstGeom prst="roundRect">
             <a:avLst>
-              <a:gd name="adj" fmla="val 3015"/>
+              <a:gd name="adj" fmla="val 4839"/>
             </a:avLst>
           </a:prstGeom>
           <a:solidFill>
@@ -20318,8 +20318,8 @@
         </p:blipFill>
         <p:spPr>
           <a:xfrm>
-            <a:off x="4238931" y="4617720"/>
-            <a:ext cx="3713833" cy="1600200"/>
+            <a:off x="5034752" y="5303520"/>
+            <a:ext cx="2122190" cy="914400"/>
           </a:xfrm>
           <a:prstGeom prst="rect">
             <a:avLst/>
@@ -21608,11 +21608,11 @@
         <p:spPr>
           <a:xfrm>
             <a:off x="640080" y="1965960"/>
-            <a:ext cx="10911535" cy="1719072"/>
+            <a:ext cx="10911535" cy="1501140"/>
           </a:xfrm>
           <a:prstGeom prst="roundRect">
             <a:avLst>
-              <a:gd name="adj" fmla="val 4255"/>
+              <a:gd name="adj" fmla="val 4873"/>
             </a:avLst>
           </a:prstGeom>
           <a:solidFill>
@@ -21630,7 +21630,7 @@
         <p:spPr>
           <a:xfrm>
             <a:off x="960120" y="2194560"/>
-            <a:ext cx="10271455" cy="1261872"/>
+            <a:ext cx="10271455" cy="1043940"/>
           </a:xfrm>
           <a:prstGeom prst="rect">
             <a:avLst/>
@@ -21731,12 +21731,12 @@
         </p:nvSpPr>
         <p:spPr>
           <a:xfrm>
-            <a:off x="530352" y="3849624"/>
-            <a:ext cx="11130991" cy="2478024"/>
+            <a:off x="530352" y="3631692"/>
+            <a:ext cx="11130991" cy="2695956"/>
           </a:xfrm>
           <a:prstGeom prst="roundRect">
             <a:avLst>
-              <a:gd name="adj" fmla="val 2214"/>
+              <a:gd name="adj" fmla="val 2035"/>
             </a:avLst>
           </a:prstGeom>
           <a:solidFill>
@@ -21773,7 +21773,7 @@
         </p:blipFill>
         <p:spPr>
           <a:xfrm>
-            <a:off x="640080" y="4323232"/>
+            <a:off x="640080" y="4214266"/>
             <a:ext cx="10911535" cy="1530807"/>
           </a:xfrm>
           <a:prstGeom prst="rect">

</xml_diff>